<commit_message>
feat: add Q5 slide to presentation, sync all slide numbers to cloud-scale results
Added a new "ANALYTICS — Q5" slide (matching the Q1-Q4 style, with a
generated bar chart) presenting the full cloud-scale weather-join finding:
demand is 62.5%/34.7%/2.8% clear/rain/snow, and avg fare/distance are
flat-to-lower on snow days, not higher. Updated the research-questions
slide to list 5 questions, the wrap-up slide with a Q5 takeaway, and
synced stale references (query count, test count, headline trip count)
across the deck.

Co-Authored-By: Claude Sonnet 5 <noreply@anthropic.com>
</commit_message>
<xml_diff>
--- a/CS675_Presentation.pptx
+++ b/CS675_Presentation.pptx
@@ -14,6 +14,7 @@
     <p:sldId id="262" r:id="rId8"/>
     <p:sldId id="263" r:id="rId9"/>
     <p:sldId id="264" r:id="rId10"/>
+    <p:sldId id="269" r:id="rId18"/>
     <p:sldId id="265" r:id="rId11"/>
     <p:sldId id="267" r:id="rId12"/>
     <p:sldId id="268" r:id="rId13"/>
@@ -3419,30 +3420,15 @@
 </file>
 
 <file path=ppt/slides/slide10.xml><?xml version="1.0" encoding="utf-8"?>
-<p:sld xmlns:a="http://schemas.openxmlformats.org/drawingml/2006/main" xmlns:r="http://schemas.openxmlformats.org/officeDocument/2006/relationships" xmlns:p="http://schemas.openxmlformats.org/presentationml/2006/main">
+<p:sld xmlns:a="http://schemas.openxmlformats.org/drawingml/2006/main" xmlns:p="http://schemas.openxmlformats.org/presentationml/2006/main" xmlns:r="http://schemas.openxmlformats.org/officeDocument/2006/relationships">
   <p:cSld>
-    <p:bg>
-      <p:bgPr>
-        <a:solidFill>
-          <a:srgbClr val="FCFCFB"/>
-        </a:solidFill>
-        <a:effectLst/>
-      </p:bgPr>
-    </p:bg>
     <p:spTree>
       <p:nvGrpSpPr>
         <p:cNvPr id="1" name=""/>
         <p:cNvGrpSpPr/>
         <p:nvPr/>
       </p:nvGrpSpPr>
-      <p:grpSpPr>
-        <a:xfrm>
-          <a:off x="0" y="0"/>
-          <a:ext cx="0" cy="0"/>
-          <a:chOff x="0" y="0"/>
-          <a:chExt cx="0" cy="0"/>
-        </a:xfrm>
-      </p:grpSpPr>
+      <p:grpSpPr/>
       <p:sp>
         <p:nvSpPr>
           <p:cNvPr id="2" name="Rectangle 1"/>
@@ -3522,7 +3508,7 @@
                 </a:solidFill>
                 <a:latin typeface="Arial"/>
               </a:rPr>
-              <a:t>ML EXTENSION  ·  +10 BONUS  ·  ~30S</a:t>
+              <a:t>ANALYTICS — Q5  ·  ~45S</a:t>
             </a:r>
           </a:p>
         </p:txBody>
@@ -3555,13 +3541,13 @@
               </a:lnSpc>
             </a:pPr>
             <a:r>
-              <a:rPr sz="3000" b="1" i="0">
+              <a:rPr sz="2700" b="1" i="0">
                 <a:solidFill>
                   <a:srgbClr val="0B0B0B"/>
                 </a:solidFill>
                 <a:latin typeface="Arial"/>
               </a:rPr>
-              <a:t>Predicting Trip Revenue</a:t>
+              <a:t>Demand by Weather Condition</a:t>
             </a:r>
           </a:p>
         </p:txBody>
@@ -3613,226 +3599,14 @@
       </p:sp>
       <p:sp>
         <p:nvSpPr>
-          <p:cNvPr id="6" name="TextBox 5"/>
-          <p:cNvSpPr txBox="1"/>
-          <p:nvPr/>
-        </p:nvSpPr>
-        <p:spPr>
-          <a:xfrm>
-            <a:off x="548640" y="1691640"/>
-            <a:ext cx="5212080" cy="365760"/>
-          </a:xfrm>
-          <a:prstGeom prst="rect">
-            <a:avLst/>
-          </a:prstGeom>
-          <a:noFill/>
-        </p:spPr>
-        <p:txBody>
-          <a:bodyPr wrap="square" anchor="t">
-            <a:spAutoFit/>
-          </a:bodyPr>
-          <a:lstStyle/>
-          <a:p>
-            <a:pPr algn="l">
-              <a:lnSpc>
-                <a:spcPct val="100000"/>
-              </a:lnSpc>
-            </a:pPr>
-            <a:r>
-              <a:rPr sz="1300" b="1" i="0">
-                <a:solidFill>
-                  <a:srgbClr val="2A78D6"/>
-                </a:solidFill>
-                <a:latin typeface="Arial"/>
-              </a:rPr>
-              <a:t>SETUP</a:t>
-            </a:r>
-          </a:p>
-        </p:txBody>
-      </p:sp>
-      <p:sp>
-        <p:nvSpPr>
-          <p:cNvPr id="7" name="TextBox 6"/>
-          <p:cNvSpPr txBox="1"/>
-          <p:nvPr/>
-        </p:nvSpPr>
-        <p:spPr>
-          <a:xfrm>
-            <a:off x="548640" y="2057400"/>
-            <a:ext cx="5212080" cy="2377440"/>
-          </a:xfrm>
-          <a:prstGeom prst="rect">
-            <a:avLst/>
-          </a:prstGeom>
-          <a:noFill/>
-        </p:spPr>
-        <p:txBody>
-          <a:bodyPr wrap="square">
-            <a:spAutoFit/>
-          </a:bodyPr>
-          <a:lstStyle/>
-          <a:p>
-            <a:pPr>
-              <a:lnSpc>
-                <a:spcPct val="112000"/>
-              </a:lnSpc>
-              <a:spcAft>
-                <a:spcPts val="1400"/>
-              </a:spcAft>
-            </a:pPr>
-            <a:r>
-              <a:rPr sz="1450" b="1">
-                <a:solidFill>
-                  <a:srgbClr val="2A78D6"/>
-                </a:solidFill>
-                <a:latin typeface="Arial"/>
-              </a:rPr>
-              <a:t>▸  </a:t>
-            </a:r>
-            <a:r>
-              <a:rPr sz="1450" b="1">
-                <a:solidFill>
-                  <a:srgbClr val="0B0B0B"/>
-                </a:solidFill>
-                <a:latin typeface="Arial"/>
-              </a:rPr>
-              <a:t>Target — </a:t>
-            </a:r>
-            <a:r>
-              <a:rPr sz="1450">
-                <a:solidFill>
-                  <a:srgbClr val="0B0B0B"/>
-                </a:solidFill>
-                <a:latin typeface="Arial"/>
-              </a:rPr>
-              <a:t>total_amount (fare + tip + tolls + surcharges) per trip</a:t>
-            </a:r>
-          </a:p>
-          <a:p>
-            <a:pPr>
-              <a:lnSpc>
-                <a:spcPct val="112000"/>
-              </a:lnSpc>
-              <a:spcAft>
-                <a:spcPts val="1400"/>
-              </a:spcAft>
-            </a:pPr>
-            <a:r>
-              <a:rPr sz="1450" b="1">
-                <a:solidFill>
-                  <a:srgbClr val="2A78D6"/>
-                </a:solidFill>
-                <a:latin typeface="Arial"/>
-              </a:rPr>
-              <a:t>▸  </a:t>
-            </a:r>
-            <a:r>
-              <a:rPr sz="1450" b="1">
-                <a:solidFill>
-                  <a:srgbClr val="0B0B0B"/>
-                </a:solidFill>
-                <a:latin typeface="Arial"/>
-              </a:rPr>
-              <a:t>8 features — </a:t>
-            </a:r>
-            <a:r>
-              <a:rPr sz="1450">
-                <a:solidFill>
-                  <a:srgbClr val="0B0B0B"/>
-                </a:solidFill>
-                <a:latin typeface="Arial"/>
-              </a:rPr>
-              <a:t>trip_distance, pickup_hour, day_of_week, passenger_count, pickup/dropoff zone (StringIndexer), pay_credit_card, pay_cash</a:t>
-            </a:r>
-          </a:p>
-          <a:p>
-            <a:pPr>
-              <a:lnSpc>
-                <a:spcPct val="112000"/>
-              </a:lnSpc>
-              <a:spcAft>
-                <a:spcPts val="1400"/>
-              </a:spcAft>
-            </a:pPr>
-            <a:r>
-              <a:rPr sz="1450" b="1">
-                <a:solidFill>
-                  <a:srgbClr val="2A78D6"/>
-                </a:solidFill>
-                <a:latin typeface="Arial"/>
-              </a:rPr>
-              <a:t>▸  </a:t>
-            </a:r>
-            <a:r>
-              <a:rPr sz="1450" b="1">
-                <a:solidFill>
-                  <a:srgbClr val="0B0B0B"/>
-                </a:solidFill>
-                <a:latin typeface="Arial"/>
-              </a:rPr>
-              <a:t>3 models compared — </a:t>
-            </a:r>
-            <a:r>
-              <a:rPr sz="1450">
-                <a:solidFill>
-                  <a:srgbClr val="0B0B0B"/>
-                </a:solidFill>
-                <a:latin typeface="Arial"/>
-              </a:rPr>
-              <a:t>Linear Regression (baseline), Gradient Boosted Trees, Random Forest — all trained on an 80/20 split, evaluated with RMSE + R²</a:t>
-            </a:r>
-          </a:p>
-        </p:txBody>
-      </p:sp>
-      <p:sp>
-        <p:nvSpPr>
-          <p:cNvPr id="8" name="TextBox 7"/>
-          <p:cNvSpPr txBox="1"/>
-          <p:nvPr/>
-        </p:nvSpPr>
-        <p:spPr>
-          <a:xfrm>
-            <a:off x="548640" y="4709160"/>
-            <a:ext cx="5212080" cy="1371600"/>
-          </a:xfrm>
-          <a:prstGeom prst="rect">
-            <a:avLst/>
-          </a:prstGeom>
-          <a:noFill/>
-        </p:spPr>
-        <p:txBody>
-          <a:bodyPr wrap="square" anchor="t">
-            <a:spAutoFit/>
-          </a:bodyPr>
-          <a:lstStyle/>
-          <a:p>
-            <a:pPr algn="l">
-              <a:lnSpc>
-                <a:spcPct val="100000"/>
-              </a:lnSpc>
-            </a:pPr>
-            <a:r>
-              <a:rPr sz="1400" b="0" i="1">
-                <a:solidFill>
-                  <a:srgbClr val="52514E"/>
-                </a:solidFill>
-                <a:latin typeface="Arial"/>
-              </a:rPr>
-              <a:t>Winner: Random Forest — RMSE $4.44, R² 0.906 (66% lower RMSE than the linear baseline). The Streamlit UI auto-loads whichever model has the lowest saved RMSE.</a:t>
-            </a:r>
-          </a:p>
-        </p:txBody>
-      </p:sp>
-      <p:sp>
-        <p:nvSpPr>
-          <p:cNvPr id="9" name="Rectangle 8"/>
+          <p:cNvPr id="6" name="Rectangle 5"/>
           <p:cNvSpPr/>
           <p:nvPr/>
         </p:nvSpPr>
         <p:spPr>
           <a:xfrm>
-            <a:off x="6101080" y="1666240"/>
-            <a:ext cx="5537200" cy="4302760"/>
+            <a:off x="523240" y="1666240"/>
+            <a:ext cx="7091680" cy="4074160"/>
           </a:xfrm>
           <a:prstGeom prst="rect">
             <a:avLst/>
@@ -3872,22 +3646,22 @@
       </p:sp>
       <p:pic>
         <p:nvPicPr>
-          <p:cNvPr id="10" name="Picture 9" descr="ml_comparison.png"/>
+          <p:cNvPr id="12" name="Picture 11" descr="q5_chart.png"/>
           <p:cNvPicPr>
             <a:picLocks noChangeAspect="1"/>
           </p:cNvPicPr>
           <p:nvPr/>
         </p:nvPicPr>
         <p:blipFill>
-          <a:blip r:embed="rId2"/>
+          <a:blip r:embed="rId3"/>
           <a:stretch>
             <a:fillRect/>
           </a:stretch>
         </p:blipFill>
         <p:spPr>
           <a:xfrm>
-            <a:off x="6126480" y="1691640"/>
-            <a:ext cx="5486400" cy="4251960"/>
+            <a:off x="548640" y="1691640"/>
+            <a:ext cx="7040880" cy="4023360"/>
           </a:xfrm>
           <a:prstGeom prst="rect">
             <a:avLst/>
@@ -3896,14 +3670,148 @@
       </p:pic>
       <p:sp>
         <p:nvSpPr>
-          <p:cNvPr id="11" name="TextBox 10"/>
+          <p:cNvPr id="8" name="TextBox 7"/>
           <p:cNvSpPr txBox="1"/>
           <p:nvPr/>
         </p:nvSpPr>
         <p:spPr>
           <a:xfrm>
-            <a:off x="548640" y="6510528"/>
-            <a:ext cx="5486400" cy="274320"/>
+            <a:off x="7818120" y="1783080"/>
+            <a:ext cx="3794760" cy="3657600"/>
+          </a:xfrm>
+          <a:prstGeom prst="rect">
+            <a:avLst/>
+          </a:prstGeom>
+          <a:noFill/>
+        </p:spPr>
+        <p:txBody>
+          <a:bodyPr wrap="square">
+            <a:spAutoFit/>
+          </a:bodyPr>
+          <a:lstStyle/>
+          <a:p>
+            <a:pPr>
+              <a:lnSpc>
+                <a:spcPct val="112000"/>
+              </a:lnSpc>
+              <a:spcAft>
+                <a:spcPts val="1400"/>
+              </a:spcAft>
+            </a:pPr>
+            <a:r>
+              <a:rPr sz="1450" b="1">
+                <a:solidFill>
+                  <a:srgbClr val="2A78D6"/>
+                </a:solidFill>
+                <a:latin typeface="Arial"/>
+              </a:rPr>
+              <a:t>▸  </a:t>
+            </a:r>
+            <a:r>
+              <a:rPr sz="1450" b="1">
+                <a:solidFill>
+                  <a:srgbClr val="0B0B0B"/>
+                </a:solidFill>
+                <a:latin typeface="Arial"/>
+              </a:rPr>
+              <a:t>Clear days dominate volume — </a:t>
+            </a:r>
+            <a:r>
+              <a:rPr sz="1450">
+                <a:solidFill>
+                  <a:srgbClr val="0B0B0B"/>
+                </a:solidFill>
+                <a:latin typeface="Arial"/>
+              </a:rPr>
+              <a:t>62.5% of trips (110.7M) vs. 34.7% rain (61.4M) and 2.8% snow (5.0M) — NYC simply gets far more rainy days than snowy ones.</a:t>
+            </a:r>
+          </a:p>
+          <a:p>
+            <a:pPr>
+              <a:lnSpc>
+                <a:spcPct val="112000"/>
+              </a:lnSpc>
+              <a:spcAft>
+                <a:spcPts val="1400"/>
+              </a:spcAft>
+            </a:pPr>
+            <a:r>
+              <a:rPr sz="1450" b="1">
+                <a:solidFill>
+                  <a:srgbClr val="2A78D6"/>
+                </a:solidFill>
+                <a:latin typeface="Arial"/>
+              </a:rPr>
+              <a:t>▸  </a:t>
+            </a:r>
+            <a:r>
+              <a:rPr sz="1450" b="1">
+                <a:solidFill>
+                  <a:srgbClr val="0B0B0B"/>
+                </a:solidFill>
+                <a:latin typeface="Arial"/>
+              </a:rPr>
+              <a:t>Fare and distance drop on snow days, not rise — </a:t>
+            </a:r>
+            <a:r>
+              <a:rPr sz="1450">
+                <a:solidFill>
+                  <a:srgbClr val="0B0B0B"/>
+                </a:solidFill>
+                <a:latin typeface="Arial"/>
+              </a:rPr>
+              <a:t>avg fare $12.65 (snow) vs. $13.57 (clear) / $13.56 (rain); avg distance 3.62mi (snow) vs. 4.47mi (clear) — the opposite of a naive “bad weather costs more” intuition.</a:t>
+            </a:r>
+          </a:p>
+          <a:p>
+            <a:pPr>
+              <a:lnSpc>
+                <a:spcPct val="112000"/>
+              </a:lnSpc>
+              <a:spcAft>
+                <a:spcPts val="1400"/>
+              </a:spcAft>
+            </a:pPr>
+            <a:r>
+              <a:rPr sz="1450" b="1">
+                <a:solidFill>
+                  <a:srgbClr val="2A78D6"/>
+                </a:solidFill>
+                <a:latin typeface="Arial"/>
+              </a:rPr>
+              <a:t>▸  </a:t>
+            </a:r>
+            <a:r>
+              <a:rPr sz="1450" b="1">
+                <a:solidFill>
+                  <a:srgbClr val="0B0B0B"/>
+                </a:solidFill>
+                <a:latin typeface="Arial"/>
+              </a:rPr>
+              <a:t>Why — </a:t>
+            </a:r>
+            <a:r>
+              <a:rPr sz="1450">
+                <a:solidFill>
+                  <a:srgbClr val="0B0B0B"/>
+                </a:solidFill>
+                <a:latin typeface="Arial"/>
+              </a:rPr>
+              <a:t>snowstorms likely suppress the longest, priciest trips (airport runs, per Q2) more than short local hops, pulling both averages down on snow days.</a:t>
+            </a:r>
+          </a:p>
+        </p:txBody>
+      </p:sp>
+      <p:sp>
+        <p:nvSpPr>
+          <p:cNvPr id="9" name="TextBox 8"/>
+          <p:cNvSpPr txBox="1"/>
+          <p:nvPr/>
+        </p:nvSpPr>
+        <p:spPr>
+          <a:xfrm>
+            <a:off x="7818120" y="5623560"/>
+            <a:ext cx="3794760" cy="640080"/>
           </a:xfrm>
           <a:prstGeom prst="rect">
             <a:avLst/>
@@ -3922,6 +3830,45 @@
               </a:lnSpc>
             </a:pPr>
             <a:r>
+              <a:rPr sz="1100" b="0" i="1">
+                <a:solidFill>
+                  <a:srgbClr val="898781"/>
+                </a:solidFill>
+                <a:latin typeface="Arial"/>
+              </a:rPr>
+              <a:t>Columns: tpep_pickup_datetime → pickup_date, joined to NOAA daily weather (PRCP, SNOW)  ·  broadcast JOIN + GROUP BY weather_condition</a:t>
+            </a:r>
+          </a:p>
+        </p:txBody>
+      </p:sp>
+      <p:sp>
+        <p:nvSpPr>
+          <p:cNvPr id="10" name="TextBox 9"/>
+          <p:cNvSpPr txBox="1"/>
+          <p:nvPr/>
+        </p:nvSpPr>
+        <p:spPr>
+          <a:xfrm>
+            <a:off x="548640" y="6510528"/>
+            <a:ext cx="5486400" cy="274320"/>
+          </a:xfrm>
+          <a:prstGeom prst="rect">
+            <a:avLst/>
+          </a:prstGeom>
+          <a:noFill/>
+        </p:spPr>
+        <p:txBody>
+          <a:bodyPr wrap="square" anchor="t">
+            <a:spAutoFit/>
+          </a:bodyPr>
+          <a:lstStyle/>
+          <a:p>
+            <a:pPr algn="l">
+              <a:lnSpc>
+                <a:spcPct val="100000"/>
+              </a:lnSpc>
+            </a:pPr>
+            <a:r>
               <a:rPr sz="900" b="0" i="0">
                 <a:solidFill>
                   <a:srgbClr val="898781"/>
@@ -3935,7 +3882,7 @@
       </p:sp>
       <p:sp>
         <p:nvSpPr>
-          <p:cNvPr id="12" name="TextBox 11"/>
+          <p:cNvPr id="11" name="TextBox 10"/>
           <p:cNvSpPr txBox="1"/>
           <p:nvPr/>
         </p:nvSpPr>
@@ -4084,7 +4031,7 @@
                 </a:solidFill>
                 <a:latin typeface="Arial"/>
               </a:rPr>
-              <a:t>WRAP-UP</a:t>
+              <a:t>ML EXTENSION  ·  +10 BONUS  ·  ~30S</a:t>
             </a:r>
           </a:p>
         </p:txBody>
@@ -4123,7 +4070,7 @@
                 </a:solidFill>
                 <a:latin typeface="Arial"/>
               </a:rPr>
-              <a:t>Summary &amp; Key Takeaways</a:t>
+              <a:t>Predicting Trip Revenue</a:t>
             </a:r>
           </a:p>
         </p:txBody>
@@ -4182,7 +4129,46 @@
         <p:spPr>
           <a:xfrm>
             <a:off x="548640" y="1691640"/>
-            <a:ext cx="10881360" cy="4206240"/>
+            <a:ext cx="5212080" cy="365760"/>
+          </a:xfrm>
+          <a:prstGeom prst="rect">
+            <a:avLst/>
+          </a:prstGeom>
+          <a:noFill/>
+        </p:spPr>
+        <p:txBody>
+          <a:bodyPr wrap="square" anchor="t">
+            <a:spAutoFit/>
+          </a:bodyPr>
+          <a:lstStyle/>
+          <a:p>
+            <a:pPr algn="l">
+              <a:lnSpc>
+                <a:spcPct val="100000"/>
+              </a:lnSpc>
+            </a:pPr>
+            <a:r>
+              <a:rPr sz="1300" b="1" i="0">
+                <a:solidFill>
+                  <a:srgbClr val="2A78D6"/>
+                </a:solidFill>
+                <a:latin typeface="Arial"/>
+              </a:rPr>
+              <a:t>SETUP</a:t>
+            </a:r>
+          </a:p>
+        </p:txBody>
+      </p:sp>
+      <p:sp>
+        <p:nvSpPr>
+          <p:cNvPr id="7" name="TextBox 6"/>
+          <p:cNvSpPr txBox="1"/>
+          <p:nvPr/>
+        </p:nvSpPr>
+        <p:spPr>
+          <a:xfrm>
+            <a:off x="548640" y="2057400"/>
+            <a:ext cx="5212080" cy="2377440"/>
           </a:xfrm>
           <a:prstGeom prst="rect">
             <a:avLst/>
@@ -4204,7 +4190,7 @@
               </a:spcAft>
             </a:pPr>
             <a:r>
-              <a:rPr sz="1600" b="1">
+              <a:rPr sz="1450" b="1">
                 <a:solidFill>
                   <a:srgbClr val="2A78D6"/>
                 </a:solidFill>
@@ -4213,22 +4199,22 @@
               <a:t>▸  </a:t>
             </a:r>
             <a:r>
-              <a:rPr sz="1600" b="1">
+              <a:rPr sz="1450" b="1">
                 <a:solidFill>
                   <a:srgbClr val="0B0B0B"/>
                 </a:solidFill>
                 <a:latin typeface="Arial"/>
               </a:rPr>
-              <a:t>Full pipeline, proven at two scales — </a:t>
-            </a:r>
-            <a:r>
-              <a:rPr sz="1600">
+              <a:t>Target — </a:t>
+            </a:r>
+            <a:r>
+              <a:rPr sz="1450">
                 <a:solidFill>
                   <a:srgbClr val="0B0B0B"/>
                 </a:solidFill>
                 <a:latin typeface="Arial"/>
               </a:rPr>
-              <a:t>raw Parquet → cleaned data → 4 analytics queries → ML model → served prediction UI, unchanged between a 2.5M-row laptop run and a 180M-row EMR Serverless run.</a:t>
+              <a:t>total_amount (fare + tip + tolls + surcharges) per trip</a:t>
             </a:r>
           </a:p>
           <a:p>
@@ -4241,7 +4227,7 @@
               </a:spcAft>
             </a:pPr>
             <a:r>
-              <a:rPr sz="1600" b="1">
+              <a:rPr sz="1450" b="1">
                 <a:solidFill>
                   <a:srgbClr val="2A78D6"/>
                 </a:solidFill>
@@ -4250,22 +4236,22 @@
               <a:t>▸  </a:t>
             </a:r>
             <a:r>
-              <a:rPr sz="1600" b="1">
+              <a:rPr sz="1450" b="1">
                 <a:solidFill>
                   <a:srgbClr val="0B0B0B"/>
                 </a:solidFill>
                 <a:latin typeface="Arial"/>
               </a:rPr>
-              <a:t>Demand is evening-shaped, not commute-shaped — </a:t>
-            </a:r>
-            <a:r>
-              <a:rPr sz="1600">
+              <a:t>8 features — </a:t>
+            </a:r>
+            <a:r>
+              <a:rPr sz="1450">
                 <a:solidFill>
                   <a:srgbClr val="0B0B0B"/>
                 </a:solidFill>
                 <a:latin typeface="Arial"/>
               </a:rPr>
-              <a:t>one peak at 18:00 on both weekdays and weekends.</a:t>
+              <a:t>trip_distance, pickup_hour, day_of_week, passenger_count, pickup/dropoff zone (StringIndexer), pay_credit_card, pay_cash</a:t>
             </a:r>
           </a:p>
           <a:p>
@@ -4278,7 +4264,7 @@
               </a:spcAft>
             </a:pPr>
             <a:r>
-              <a:rPr sz="1600" b="1">
+              <a:rPr sz="1450" b="1">
                 <a:solidFill>
                   <a:srgbClr val="2A78D6"/>
                 </a:solidFill>
@@ -4287,147 +4273,36 @@
               <a:t>▸  </a:t>
             </a:r>
             <a:r>
-              <a:rPr sz="1600" b="1">
+              <a:rPr sz="1450" b="1">
                 <a:solidFill>
                   <a:srgbClr val="0B0B0B"/>
                 </a:solidFill>
                 <a:latin typeface="Arial"/>
               </a:rPr>
-              <a:t>Airport trips drive revenue, not volume — </a:t>
-            </a:r>
-            <a:r>
-              <a:rPr sz="1600">
+              <a:t>3 models compared — </a:t>
+            </a:r>
+            <a:r>
+              <a:rPr sz="1450">
                 <a:solidFill>
                   <a:srgbClr val="0B0B0B"/>
                 </a:solidFill>
                 <a:latin typeface="Arial"/>
               </a:rPr>
-              <a:t>JFK/LGA rank #1/#2 in total revenue on far fewer trips, purely on fare-per-trip.</a:t>
-            </a:r>
-          </a:p>
-          <a:p>
-            <a:pPr>
-              <a:lnSpc>
-                <a:spcPct val="112000"/>
-              </a:lnSpc>
-              <a:spcAft>
-                <a:spcPts val="1400"/>
-              </a:spcAft>
-            </a:pPr>
-            <a:r>
-              <a:rPr sz="1600" b="1">
-                <a:solidFill>
-                  <a:srgbClr val="2A78D6"/>
-                </a:solidFill>
-                <a:latin typeface="Arial"/>
-              </a:rPr>
-              <a:t>▸  </a:t>
-            </a:r>
-            <a:r>
-              <a:rPr sz="1600" b="1">
-                <a:solidFill>
-                  <a:srgbClr val="0B0B0B"/>
-                </a:solidFill>
-                <a:latin typeface="Arial"/>
-              </a:rPr>
-              <a:t>The flat base fare explains two patterns at once — </a:t>
-            </a:r>
-            <a:r>
-              <a:rPr sz="1600">
-                <a:solidFill>
-                  <a:srgbClr val="0B0B0B"/>
-                </a:solidFill>
-                <a:latin typeface="Arial"/>
-              </a:rPr>
-              <a:t>why short trips tip the highest % and cost the most per mile.</a:t>
-            </a:r>
-          </a:p>
-          <a:p>
-            <a:pPr>
-              <a:lnSpc>
-                <a:spcPct val="112000"/>
-              </a:lnSpc>
-              <a:spcAft>
-                <a:spcPts val="1400"/>
-              </a:spcAft>
-            </a:pPr>
-            <a:r>
-              <a:rPr sz="1600" b="1">
-                <a:solidFill>
-                  <a:srgbClr val="2A78D6"/>
-                </a:solidFill>
-                <a:latin typeface="Arial"/>
-              </a:rPr>
-              <a:t>▸  </a:t>
-            </a:r>
-            <a:r>
-              <a:rPr sz="1600" b="1">
-                <a:solidFill>
-                  <a:srgbClr val="0B0B0B"/>
-                </a:solidFill>
-                <a:latin typeface="Arial"/>
-              </a:rPr>
-              <a:t>Random Forest cut prediction error by 66%</a:t>
-            </a:r>
-            <a:r>
-              <a:rPr sz="1600">
-                <a:solidFill>
-                  <a:srgbClr val="0B0B0B"/>
-                </a:solidFill>
-                <a:latin typeface="Arial"/>
-              </a:rPr>
-              <a:t> over the linear baseline (RMSE $13.22 → $4.44) and is what actually serves the UI.</a:t>
-            </a:r>
-          </a:p>
-          <a:p>
-            <a:pPr>
-              <a:lnSpc>
-                <a:spcPct val="112000"/>
-              </a:lnSpc>
-              <a:spcAft>
-                <a:spcPts val="1400"/>
-              </a:spcAft>
-            </a:pPr>
-            <a:r>
-              <a:rPr sz="1600" b="1">
-                <a:solidFill>
-                  <a:srgbClr val="2A78D6"/>
-                </a:solidFill>
-                <a:latin typeface="Arial"/>
-              </a:rPr>
-              <a:t>▸  </a:t>
-            </a:r>
-            <a:r>
-              <a:rPr sz="1600" b="1">
-                <a:solidFill>
-                  <a:srgbClr val="0B0B0B"/>
-                </a:solidFill>
-                <a:latin typeface="Arial"/>
-              </a:rPr>
-              <a:t>≥ 2 course tools satisfied — </a:t>
-            </a:r>
-            <a:r>
-              <a:rPr sz="1600">
-                <a:solidFill>
-                  <a:srgbClr val="0B0B0B"/>
-                </a:solidFill>
-                <a:latin typeface="Arial"/>
-              </a:rPr>
-              <a:t>PySpark, AWS Athena, AWS EMR Serverless, Terraform.</a:t>
-            </a:r>
-          </a:p>
-        </p:txBody>
-      </p:sp>
-      <p:sp>
-        <p:nvSpPr>
-          <p:cNvPr id="7" name="TextBox 6"/>
+              <a:t>Linear Regression (baseline), Gradient Boosted Trees, Random Forest — all trained on an 80/20 split, evaluated with RMSE + R²</a:t>
+            </a:r>
+          </a:p>
+        </p:txBody>
+      </p:sp>
+      <p:sp>
+        <p:nvSpPr>
+          <p:cNvPr id="8" name="TextBox 7"/>
           <p:cNvSpPr txBox="1"/>
           <p:nvPr/>
         </p:nvSpPr>
         <p:spPr>
           <a:xfrm>
-            <a:off x="548640" y="6510528"/>
-            <a:ext cx="5486400" cy="274320"/>
+            <a:off x="548640" y="4709160"/>
+            <a:ext cx="5212080" cy="1371600"/>
           </a:xfrm>
           <a:prstGeom prst="rect">
             <a:avLst/>
@@ -4446,27 +4321,98 @@
               </a:lnSpc>
             </a:pPr>
             <a:r>
-              <a:rPr sz="900" b="0" i="0">
-                <a:solidFill>
-                  <a:srgbClr val="898781"/>
-                </a:solidFill>
-                <a:latin typeface="Arial"/>
-              </a:rPr>
-              <a:t>CS675 — NYC Yellow Taxi Analytics at Cloud Scale</a:t>
-            </a:r>
-          </a:p>
-        </p:txBody>
-      </p:sp>
-      <p:sp>
-        <p:nvSpPr>
-          <p:cNvPr id="8" name="TextBox 7"/>
+              <a:rPr sz="1400" b="0" i="1">
+                <a:solidFill>
+                  <a:srgbClr val="52514E"/>
+                </a:solidFill>
+                <a:latin typeface="Arial"/>
+              </a:rPr>
+              <a:t>Winner: Random Forest — RMSE $4.44, R² 0.906 (66% lower RMSE than the linear baseline). The Streamlit UI auto-loads whichever model has the lowest saved RMSE.</a:t>
+            </a:r>
+          </a:p>
+        </p:txBody>
+      </p:sp>
+      <p:sp>
+        <p:nvSpPr>
+          <p:cNvPr id="9" name="Rectangle 8"/>
+          <p:cNvSpPr/>
+          <p:nvPr/>
+        </p:nvSpPr>
+        <p:spPr>
+          <a:xfrm>
+            <a:off x="6101080" y="1666240"/>
+            <a:ext cx="5537200" cy="4302760"/>
+          </a:xfrm>
+          <a:prstGeom prst="rect">
+            <a:avLst/>
+          </a:prstGeom>
+          <a:solidFill>
+            <a:srgbClr val="FFFFFF"/>
+          </a:solidFill>
+          <a:ln w="12700">
+            <a:solidFill>
+              <a:srgbClr val="E1E0D9"/>
+            </a:solidFill>
+          </a:ln>
+          <a:effectLst/>
+        </p:spPr>
+        <p:style>
+          <a:lnRef idx="1">
+            <a:schemeClr val="accent1"/>
+          </a:lnRef>
+          <a:fillRef idx="3">
+            <a:schemeClr val="accent1"/>
+          </a:fillRef>
+          <a:effectRef idx="2">
+            <a:schemeClr val="accent1"/>
+          </a:effectRef>
+          <a:fontRef idx="minor">
+            <a:schemeClr val="lt1"/>
+          </a:fontRef>
+        </p:style>
+        <p:txBody>
+          <a:bodyPr rtlCol="0" anchor="ctr"/>
+          <a:lstStyle/>
+          <a:p>
+            <a:pPr algn="ctr"/>
+            <a:endParaRPr/>
+          </a:p>
+        </p:txBody>
+      </p:sp>
+      <p:pic>
+        <p:nvPicPr>
+          <p:cNvPr id="10" name="Picture 9" descr="ml_comparison.png"/>
+          <p:cNvPicPr>
+            <a:picLocks noChangeAspect="1"/>
+          </p:cNvPicPr>
+          <p:nvPr/>
+        </p:nvPicPr>
+        <p:blipFill>
+          <a:blip r:embed="rId2"/>
+          <a:stretch>
+            <a:fillRect/>
+          </a:stretch>
+        </p:blipFill>
+        <p:spPr>
+          <a:xfrm>
+            <a:off x="6126480" y="1691640"/>
+            <a:ext cx="5486400" cy="4251960"/>
+          </a:xfrm>
+          <a:prstGeom prst="rect">
+            <a:avLst/>
+          </a:prstGeom>
+        </p:spPr>
+      </p:pic>
+      <p:sp>
+        <p:nvSpPr>
+          <p:cNvPr id="11" name="TextBox 10"/>
           <p:cNvSpPr txBox="1"/>
           <p:nvPr/>
         </p:nvSpPr>
         <p:spPr>
           <a:xfrm>
-            <a:off x="11155680" y="6510528"/>
-            <a:ext cx="548640" cy="274320"/>
+            <a:off x="548640" y="6510528"/>
+            <a:ext cx="5486400" cy="274320"/>
           </a:xfrm>
           <a:prstGeom prst="rect">
             <a:avLst/>
@@ -4479,6 +4425,45 @@
           </a:bodyPr>
           <a:lstStyle/>
           <a:p>
+            <a:pPr algn="l">
+              <a:lnSpc>
+                <a:spcPct val="100000"/>
+              </a:lnSpc>
+            </a:pPr>
+            <a:r>
+              <a:rPr sz="900" b="0" i="0">
+                <a:solidFill>
+                  <a:srgbClr val="898781"/>
+                </a:solidFill>
+                <a:latin typeface="Arial"/>
+              </a:rPr>
+              <a:t>CS675 — NYC Yellow Taxi Analytics at Cloud Scale</a:t>
+            </a:r>
+          </a:p>
+        </p:txBody>
+      </p:sp>
+      <p:sp>
+        <p:nvSpPr>
+          <p:cNvPr id="12" name="TextBox 11"/>
+          <p:cNvSpPr txBox="1"/>
+          <p:nvPr/>
+        </p:nvSpPr>
+        <p:spPr>
+          <a:xfrm>
+            <a:off x="11155680" y="6510528"/>
+            <a:ext cx="548640" cy="274320"/>
+          </a:xfrm>
+          <a:prstGeom prst="rect">
+            <a:avLst/>
+          </a:prstGeom>
+          <a:noFill/>
+        </p:spPr>
+        <p:txBody>
+          <a:bodyPr wrap="square" anchor="t">
+            <a:spAutoFit/>
+          </a:bodyPr>
+          <a:lstStyle/>
+          <a:p>
             <a:pPr algn="r">
               <a:lnSpc>
                 <a:spcPct val="100000"/>
@@ -4491,7 +4476,7 @@
                 </a:solidFill>
                 <a:latin typeface="Arial"/>
               </a:rPr>
-              <a:t>12</a:t>
+              <a:t>11</a:t>
             </a:r>
           </a:p>
         </p:txBody>
@@ -4505,6 +4490,567 @@
 </file>
 
 <file path=ppt/slides/slide12.xml><?xml version="1.0" encoding="utf-8"?>
+<p:sld xmlns:a="http://schemas.openxmlformats.org/drawingml/2006/main" xmlns:r="http://schemas.openxmlformats.org/officeDocument/2006/relationships" xmlns:p="http://schemas.openxmlformats.org/presentationml/2006/main">
+  <p:cSld>
+    <p:bg>
+      <p:bgPr>
+        <a:solidFill>
+          <a:srgbClr val="FCFCFB"/>
+        </a:solidFill>
+        <a:effectLst/>
+      </p:bgPr>
+    </p:bg>
+    <p:spTree>
+      <p:nvGrpSpPr>
+        <p:cNvPr id="1" name=""/>
+        <p:cNvGrpSpPr/>
+        <p:nvPr/>
+      </p:nvGrpSpPr>
+      <p:grpSpPr>
+        <a:xfrm>
+          <a:off x="0" y="0"/>
+          <a:ext cx="0" cy="0"/>
+          <a:chOff x="0" y="0"/>
+          <a:chExt cx="0" cy="0"/>
+        </a:xfrm>
+      </p:grpSpPr>
+      <p:sp>
+        <p:nvSpPr>
+          <p:cNvPr id="2" name="Rectangle 1"/>
+          <p:cNvSpPr/>
+          <p:nvPr/>
+        </p:nvSpPr>
+        <p:spPr>
+          <a:xfrm>
+            <a:off x="0" y="0"/>
+            <a:ext cx="12191695" cy="128016"/>
+          </a:xfrm>
+          <a:prstGeom prst="rect">
+            <a:avLst/>
+          </a:prstGeom>
+          <a:solidFill>
+            <a:srgbClr val="2A78D6"/>
+          </a:solidFill>
+          <a:ln>
+            <a:noFill/>
+          </a:ln>
+          <a:effectLst/>
+        </p:spPr>
+        <p:style>
+          <a:lnRef idx="1">
+            <a:schemeClr val="accent1"/>
+          </a:lnRef>
+          <a:fillRef idx="3">
+            <a:schemeClr val="accent1"/>
+          </a:fillRef>
+          <a:effectRef idx="2">
+            <a:schemeClr val="accent1"/>
+          </a:effectRef>
+          <a:fontRef idx="minor">
+            <a:schemeClr val="lt1"/>
+          </a:fontRef>
+        </p:style>
+        <p:txBody>
+          <a:bodyPr rtlCol="0" anchor="ctr"/>
+          <a:lstStyle/>
+          <a:p>
+            <a:pPr algn="ctr"/>
+            <a:endParaRPr/>
+          </a:p>
+        </p:txBody>
+      </p:sp>
+      <p:sp>
+        <p:nvSpPr>
+          <p:cNvPr id="3" name="TextBox 2"/>
+          <p:cNvSpPr txBox="1"/>
+          <p:nvPr/>
+        </p:nvSpPr>
+        <p:spPr>
+          <a:xfrm>
+            <a:off x="548640" y="320040"/>
+            <a:ext cx="9144000" cy="320040"/>
+          </a:xfrm>
+          <a:prstGeom prst="rect">
+            <a:avLst/>
+          </a:prstGeom>
+          <a:noFill/>
+        </p:spPr>
+        <p:txBody>
+          <a:bodyPr wrap="square" anchor="t">
+            <a:spAutoFit/>
+          </a:bodyPr>
+          <a:lstStyle/>
+          <a:p>
+            <a:pPr algn="l">
+              <a:lnSpc>
+                <a:spcPct val="100000"/>
+              </a:lnSpc>
+            </a:pPr>
+            <a:r>
+              <a:rPr sz="1300" b="1" i="0">
+                <a:solidFill>
+                  <a:srgbClr val="898781"/>
+                </a:solidFill>
+                <a:latin typeface="Arial"/>
+              </a:rPr>
+              <a:t>WRAP-UP</a:t>
+            </a:r>
+          </a:p>
+        </p:txBody>
+      </p:sp>
+      <p:sp>
+        <p:nvSpPr>
+          <p:cNvPr id="4" name="TextBox 3"/>
+          <p:cNvSpPr txBox="1"/>
+          <p:nvPr/>
+        </p:nvSpPr>
+        <p:spPr>
+          <a:xfrm>
+            <a:off x="548640" y="594360"/>
+            <a:ext cx="10789920" cy="822960"/>
+          </a:xfrm>
+          <a:prstGeom prst="rect">
+            <a:avLst/>
+          </a:prstGeom>
+          <a:noFill/>
+        </p:spPr>
+        <p:txBody>
+          <a:bodyPr wrap="square" anchor="t">
+            <a:spAutoFit/>
+          </a:bodyPr>
+          <a:lstStyle/>
+          <a:p>
+            <a:pPr algn="l">
+              <a:lnSpc>
+                <a:spcPct val="100000"/>
+              </a:lnSpc>
+            </a:pPr>
+            <a:r>
+              <a:rPr sz="3000" b="1" i="0">
+                <a:solidFill>
+                  <a:srgbClr val="0B0B0B"/>
+                </a:solidFill>
+                <a:latin typeface="Arial"/>
+              </a:rPr>
+              <a:t>Summary &amp; Key Takeaways</a:t>
+            </a:r>
+          </a:p>
+        </p:txBody>
+      </p:sp>
+      <p:sp>
+        <p:nvSpPr>
+          <p:cNvPr id="5" name="Rectangle 4"/>
+          <p:cNvSpPr/>
+          <p:nvPr/>
+        </p:nvSpPr>
+        <p:spPr>
+          <a:xfrm>
+            <a:off x="548640" y="1371600"/>
+            <a:ext cx="1005840" cy="38100"/>
+          </a:xfrm>
+          <a:prstGeom prst="rect">
+            <a:avLst/>
+          </a:prstGeom>
+          <a:solidFill>
+            <a:srgbClr val="EB6834"/>
+          </a:solidFill>
+          <a:ln>
+            <a:noFill/>
+          </a:ln>
+          <a:effectLst/>
+        </p:spPr>
+        <p:style>
+          <a:lnRef idx="1">
+            <a:schemeClr val="accent1"/>
+          </a:lnRef>
+          <a:fillRef idx="3">
+            <a:schemeClr val="accent1"/>
+          </a:fillRef>
+          <a:effectRef idx="2">
+            <a:schemeClr val="accent1"/>
+          </a:effectRef>
+          <a:fontRef idx="minor">
+            <a:schemeClr val="lt1"/>
+          </a:fontRef>
+        </p:style>
+        <p:txBody>
+          <a:bodyPr rtlCol="0" anchor="ctr"/>
+          <a:lstStyle/>
+          <a:p>
+            <a:pPr algn="ctr"/>
+            <a:endParaRPr/>
+          </a:p>
+        </p:txBody>
+      </p:sp>
+      <p:sp>
+        <p:nvSpPr>
+          <p:cNvPr id="6" name="TextBox 5"/>
+          <p:cNvSpPr txBox="1"/>
+          <p:nvPr/>
+        </p:nvSpPr>
+        <p:spPr>
+          <a:xfrm>
+            <a:off x="548640" y="1691640"/>
+            <a:ext cx="10881360" cy="4206240"/>
+          </a:xfrm>
+          <a:prstGeom prst="rect">
+            <a:avLst/>
+          </a:prstGeom>
+          <a:noFill/>
+        </p:spPr>
+        <p:txBody>
+          <a:bodyPr wrap="square">
+            <a:spAutoFit/>
+          </a:bodyPr>
+          <a:lstStyle/>
+          <a:p>
+            <a:pPr>
+              <a:lnSpc>
+                <a:spcPct val="112000"/>
+              </a:lnSpc>
+              <a:spcAft>
+                <a:spcPts val="1400"/>
+              </a:spcAft>
+            </a:pPr>
+            <a:r>
+              <a:rPr sz="1600" b="1">
+                <a:solidFill>
+                  <a:srgbClr val="2A78D6"/>
+                </a:solidFill>
+                <a:latin typeface="Arial"/>
+              </a:rPr>
+              <a:t>▸  </a:t>
+            </a:r>
+            <a:r>
+              <a:rPr sz="1600" b="1">
+                <a:solidFill>
+                  <a:srgbClr val="0B0B0B"/>
+                </a:solidFill>
+                <a:latin typeface="Arial"/>
+              </a:rPr>
+              <a:t>Full pipeline, proven at two scales — </a:t>
+            </a:r>
+            <a:r>
+              <a:rPr sz="1600">
+                <a:solidFill>
+                  <a:srgbClr val="0B0B0B"/>
+                </a:solidFill>
+                <a:latin typeface="Arial"/>
+              </a:rPr>
+              <a:t>raw Parquet → cleaned data → 5 analytics queries → ML model → served prediction UI, unchanged between a 2.5M-row laptop run and a 180M-row EMR Serverless run.</a:t>
+            </a:r>
+          </a:p>
+          <a:p>
+            <a:pPr>
+              <a:lnSpc>
+                <a:spcPct val="112000"/>
+              </a:lnSpc>
+              <a:spcAft>
+                <a:spcPts val="1400"/>
+              </a:spcAft>
+            </a:pPr>
+            <a:r>
+              <a:rPr sz="1600" b="1">
+                <a:solidFill>
+                  <a:srgbClr val="2A78D6"/>
+                </a:solidFill>
+                <a:latin typeface="Arial"/>
+              </a:rPr>
+              <a:t>▸  </a:t>
+            </a:r>
+            <a:r>
+              <a:rPr sz="1600" b="1">
+                <a:solidFill>
+                  <a:srgbClr val="0B0B0B"/>
+                </a:solidFill>
+                <a:latin typeface="Arial"/>
+              </a:rPr>
+              <a:t>Demand is evening-shaped, not commute-shaped — </a:t>
+            </a:r>
+            <a:r>
+              <a:rPr sz="1600">
+                <a:solidFill>
+                  <a:srgbClr val="0B0B0B"/>
+                </a:solidFill>
+                <a:latin typeface="Arial"/>
+              </a:rPr>
+              <a:t>one peak at 18:00 on both weekdays and weekends.</a:t>
+            </a:r>
+          </a:p>
+          <a:p>
+            <a:pPr>
+              <a:lnSpc>
+                <a:spcPct val="112000"/>
+              </a:lnSpc>
+              <a:spcAft>
+                <a:spcPts val="1400"/>
+              </a:spcAft>
+            </a:pPr>
+            <a:r>
+              <a:rPr sz="1600" b="1">
+                <a:solidFill>
+                  <a:srgbClr val="2A78D6"/>
+                </a:solidFill>
+                <a:latin typeface="Arial"/>
+              </a:rPr>
+              <a:t>▸  </a:t>
+            </a:r>
+            <a:r>
+              <a:rPr sz="1600" b="1">
+                <a:solidFill>
+                  <a:srgbClr val="0B0B0B"/>
+                </a:solidFill>
+                <a:latin typeface="Arial"/>
+              </a:rPr>
+              <a:t>Airport trips drive revenue, not volume — </a:t>
+            </a:r>
+            <a:r>
+              <a:rPr sz="1600">
+                <a:solidFill>
+                  <a:srgbClr val="0B0B0B"/>
+                </a:solidFill>
+                <a:latin typeface="Arial"/>
+              </a:rPr>
+              <a:t>JFK/LGA rank #1/#2 in total revenue on far fewer trips, purely on fare-per-trip.</a:t>
+            </a:r>
+          </a:p>
+          <a:p>
+            <a:pPr>
+              <a:lnSpc>
+                <a:spcPct val="112000"/>
+              </a:lnSpc>
+              <a:spcAft>
+                <a:spcPts val="1400"/>
+              </a:spcAft>
+            </a:pPr>
+            <a:r>
+              <a:rPr sz="1600" b="1">
+                <a:solidFill>
+                  <a:srgbClr val="2A78D6"/>
+                </a:solidFill>
+                <a:latin typeface="Arial"/>
+              </a:rPr>
+              <a:t>▸  </a:t>
+            </a:r>
+            <a:r>
+              <a:rPr sz="1600" b="1">
+                <a:solidFill>
+                  <a:srgbClr val="0B0B0B"/>
+                </a:solidFill>
+                <a:latin typeface="Arial"/>
+              </a:rPr>
+              <a:t>The flat base fare explains two patterns at once — </a:t>
+            </a:r>
+            <a:r>
+              <a:rPr sz="1600">
+                <a:solidFill>
+                  <a:srgbClr val="0B0B0B"/>
+                </a:solidFill>
+                <a:latin typeface="Arial"/>
+              </a:rPr>
+              <a:t>why short trips tip the highest % and cost the most per mile.</a:t>
+            </a:r>
+          </a:p>
+          <a:p>
+            <a:pPr>
+              <a:lnSpc>
+                <a:spcPct val="112000"/>
+              </a:lnSpc>
+              <a:spcAft>
+                <a:spcPts val="1400"/>
+              </a:spcAft>
+            </a:pPr>
+            <a:r>
+              <a:rPr sz="1600" b="1">
+                <a:solidFill>
+                  <a:srgbClr val="2A78D6"/>
+                </a:solidFill>
+                <a:latin typeface="Arial"/>
+              </a:rPr>
+              <a:t>▸  </a:t>
+            </a:r>
+            <a:r>
+              <a:rPr sz="1600" b="1">
+                <a:solidFill>
+                  <a:srgbClr val="0B0B0B"/>
+                </a:solidFill>
+                <a:latin typeface="Arial"/>
+              </a:rPr>
+              <a:t>Random Forest cut prediction error by 66%</a:t>
+            </a:r>
+            <a:r>
+              <a:rPr sz="1600">
+                <a:solidFill>
+                  <a:srgbClr val="0B0B0B"/>
+                </a:solidFill>
+                <a:latin typeface="Arial"/>
+              </a:rPr>
+              <a:t> over the linear baseline (RMSE $13.22 → $4.44) and is what actually serves the UI.</a:t>
+            </a:r>
+          </a:p>
+          <a:p>
+            <a:pPr>
+              <a:lnSpc>
+                <a:spcPct val="112000"/>
+              </a:lnSpc>
+              <a:spcAft>
+                <a:spcPts val="1400"/>
+              </a:spcAft>
+            </a:pPr>
+            <a:r>
+              <a:rPr sz="1600" b="1">
+                <a:solidFill>
+                  <a:srgbClr val="2A78D6"/>
+                </a:solidFill>
+                <a:latin typeface="Arial"/>
+              </a:rPr>
+              <a:t>▸  </a:t>
+            </a:r>
+            <a:r>
+              <a:rPr sz="1600" b="1">
+                <a:solidFill>
+                  <a:srgbClr val="0B0B0B"/>
+                </a:solidFill>
+                <a:latin typeface="Arial"/>
+              </a:rPr>
+              <a:t>≥ 2 course tools satisfied — </a:t>
+            </a:r>
+            <a:r>
+              <a:rPr sz="1600">
+                <a:solidFill>
+                  <a:srgbClr val="0B0B0B"/>
+                </a:solidFill>
+                <a:latin typeface="Arial"/>
+              </a:rPr>
+              <a:t>PySpark, AWS Athena, AWS EMR Serverless, Terraform.</a:t>
+            </a:r>
+          </a:p>
+          <a:p>
+            <a:pPr>
+              <a:lnSpc>
+                <a:spcPct val="112000"/>
+              </a:lnSpc>
+              <a:spcAft>
+                <a:spcPts val="1400"/>
+              </a:spcAft>
+            </a:pPr>
+            <a:r>
+              <a:rPr sz="1600" b="1">
+                <a:solidFill>
+                  <a:srgbClr val="2A78D6"/>
+                </a:solidFill>
+                <a:latin typeface="Arial"/>
+              </a:rPr>
+              <a:t>▸  </a:t>
+            </a:r>
+            <a:r>
+              <a:rPr sz="1600" b="1">
+                <a:solidFill>
+                  <a:srgbClr val="0B0B0B"/>
+                </a:solidFill>
+                <a:latin typeface="Arial"/>
+              </a:rPr>
+              <a:t>Weather barely moves the needle at full scale — </a:t>
+            </a:r>
+            <a:r>
+              <a:rPr sz="1600">
+                <a:solidFill>
+                  <a:srgbClr val="0B0B0B"/>
+                </a:solidFill>
+                <a:latin typeface="Arial"/>
+              </a:rPr>
+              <a:t>the cross-source join (Q5) shows avg fare/distance flat-to-lower on snow days, not higher, once you have all 177M trips instead of one snowy month.</a:t>
+            </a:r>
+          </a:p>
+        </p:txBody>
+      </p:sp>
+      <p:sp>
+        <p:nvSpPr>
+          <p:cNvPr id="7" name="TextBox 6"/>
+          <p:cNvSpPr txBox="1"/>
+          <p:nvPr/>
+        </p:nvSpPr>
+        <p:spPr>
+          <a:xfrm>
+            <a:off x="548640" y="6510528"/>
+            <a:ext cx="5486400" cy="274320"/>
+          </a:xfrm>
+          <a:prstGeom prst="rect">
+            <a:avLst/>
+          </a:prstGeom>
+          <a:noFill/>
+        </p:spPr>
+        <p:txBody>
+          <a:bodyPr wrap="square" anchor="t">
+            <a:spAutoFit/>
+          </a:bodyPr>
+          <a:lstStyle/>
+          <a:p>
+            <a:pPr algn="l">
+              <a:lnSpc>
+                <a:spcPct val="100000"/>
+              </a:lnSpc>
+            </a:pPr>
+            <a:r>
+              <a:rPr sz="900" b="0" i="0">
+                <a:solidFill>
+                  <a:srgbClr val="898781"/>
+                </a:solidFill>
+                <a:latin typeface="Arial"/>
+              </a:rPr>
+              <a:t>CS675 — NYC Yellow Taxi Analytics at Cloud Scale</a:t>
+            </a:r>
+          </a:p>
+        </p:txBody>
+      </p:sp>
+      <p:sp>
+        <p:nvSpPr>
+          <p:cNvPr id="8" name="TextBox 7"/>
+          <p:cNvSpPr txBox="1"/>
+          <p:nvPr/>
+        </p:nvSpPr>
+        <p:spPr>
+          <a:xfrm>
+            <a:off x="11155680" y="6510528"/>
+            <a:ext cx="548640" cy="274320"/>
+          </a:xfrm>
+          <a:prstGeom prst="rect">
+            <a:avLst/>
+          </a:prstGeom>
+          <a:noFill/>
+        </p:spPr>
+        <p:txBody>
+          <a:bodyPr wrap="square" anchor="t">
+            <a:spAutoFit/>
+          </a:bodyPr>
+          <a:lstStyle/>
+          <a:p>
+            <a:pPr algn="r">
+              <a:lnSpc>
+                <a:spcPct val="100000"/>
+              </a:lnSpc>
+            </a:pPr>
+            <a:r>
+              <a:rPr sz="900" b="0" i="0">
+                <a:solidFill>
+                  <a:srgbClr val="898781"/>
+                </a:solidFill>
+                <a:latin typeface="Arial"/>
+              </a:rPr>
+              <a:t>13</a:t>
+            </a:r>
+          </a:p>
+        </p:txBody>
+      </p:sp>
+    </p:spTree>
+  </p:cSld>
+  <p:clrMapOvr>
+    <a:masterClrMapping/>
+  </p:clrMapOvr>
+</p:sld>
+</file>
+
+<file path=ppt/slides/slide13.xml><?xml version="1.0" encoding="utf-8"?>
 <p:sld xmlns:a="http://schemas.openxmlformats.org/drawingml/2006/main" xmlns:r="http://schemas.openxmlformats.org/officeDocument/2006/relationships" xmlns:p="http://schemas.openxmlformats.org/presentationml/2006/main">
   <p:cSld>
     <p:bg>
@@ -4725,7 +5271,7 @@
                 </a:solidFill>
                 <a:latin typeface="Arial"/>
               </a:rPr>
-              <a:t>13</a:t>
+              <a:t>14</a:t>
             </a:r>
           </a:p>
         </p:txBody>
@@ -5060,7 +5606,7 @@
                 </a:solidFill>
                 <a:latin typeface="Arial"/>
               </a:rPr>
-              <a:t>one PySpark codebase that cleans the data, answers 4 analytical questions, trains a revenue-prediction model, and serves it — running unchanged on a 2.5M-row laptop slice and a 180M-row cloud run.</a:t>
+              <a:t>one PySpark codebase that cleans the data, answers 5 analytical questions, trains a revenue-prediction model, and serves it — running unchanged on a 2.5M-row laptop slice and a 180M-row cloud run.</a:t>
             </a:r>
           </a:p>
         </p:txBody>
@@ -5146,7 +5692,7 @@
                 </a:solidFill>
                 <a:latin typeface="Arial"/>
               </a:rPr>
-              <a:t>4 RESEARCH QUESTIONS</a:t>
+              <a:t>5 RESEARCH QUESTIONS</a:t>
             </a:r>
           </a:p>
         </p:txBody>
@@ -5282,7 +5828,7 @@
         </p:nvSpPr>
         <p:spPr>
           <a:xfrm>
-            <a:off x="6812280" y="3264408"/>
+            <a:off x="6812280" y="3086100"/>
             <a:ext cx="457200" cy="457200"/>
           </a:xfrm>
           <a:prstGeom prst="rect">
@@ -5327,7 +5873,7 @@
         </p:nvSpPr>
         <p:spPr>
           <a:xfrm>
-            <a:off x="6812280" y="3300984"/>
+            <a:off x="6812280" y="3122676"/>
             <a:ext cx="457200" cy="384048"/>
           </a:xfrm>
           <a:prstGeom prst="rect">
@@ -5366,7 +5912,7 @@
         </p:nvSpPr>
         <p:spPr>
           <a:xfrm>
-            <a:off x="7452360" y="3264408"/>
+            <a:off x="7452360" y="3086100"/>
             <a:ext cx="4023360" cy="777240"/>
           </a:xfrm>
           <a:prstGeom prst="rect">
@@ -5405,7 +5951,7 @@
         </p:nvSpPr>
         <p:spPr>
           <a:xfrm>
-            <a:off x="6812280" y="4197096"/>
+            <a:off x="6812280" y="3840480"/>
             <a:ext cx="457200" cy="457200"/>
           </a:xfrm>
           <a:prstGeom prst="rect">
@@ -5450,7 +5996,7 @@
         </p:nvSpPr>
         <p:spPr>
           <a:xfrm>
-            <a:off x="6812280" y="4233672"/>
+            <a:off x="6812280" y="3877056"/>
             <a:ext cx="457200" cy="384048"/>
           </a:xfrm>
           <a:prstGeom prst="rect">
@@ -5489,7 +6035,7 @@
         </p:nvSpPr>
         <p:spPr>
           <a:xfrm>
-            <a:off x="7452360" y="4197096"/>
+            <a:off x="7452360" y="3840480"/>
             <a:ext cx="4023360" cy="777240"/>
           </a:xfrm>
           <a:prstGeom prst="rect">
@@ -5528,7 +6074,7 @@
         </p:nvSpPr>
         <p:spPr>
           <a:xfrm>
-            <a:off x="6812280" y="5129784"/>
+            <a:off x="6812280" y="4594860"/>
             <a:ext cx="457200" cy="457200"/>
           </a:xfrm>
           <a:prstGeom prst="rect">
@@ -5573,7 +6119,7 @@
         </p:nvSpPr>
         <p:spPr>
           <a:xfrm>
-            <a:off x="6812280" y="5166360"/>
+            <a:off x="6812280" y="4631436"/>
             <a:ext cx="457200" cy="384048"/>
           </a:xfrm>
           <a:prstGeom prst="rect">
@@ -5612,7 +6158,7 @@
         </p:nvSpPr>
         <p:spPr>
           <a:xfrm>
-            <a:off x="7452360" y="5129784"/>
+            <a:off x="7452360" y="4594860"/>
             <a:ext cx="4023360" cy="777240"/>
           </a:xfrm>
           <a:prstGeom prst="rect">
@@ -5717,6 +6263,129 @@
                 <a:latin typeface="Arial"/>
               </a:rPr>
               <a:t>2</a:t>
+            </a:r>
+          </a:p>
+        </p:txBody>
+      </p:sp>
+      <p:sp>
+        <p:nvSpPr>
+          <p:cNvPr id="18" name="Rectangle 17"/>
+          <p:cNvSpPr/>
+          <p:nvPr/>
+        </p:nvSpPr>
+        <p:spPr>
+          <a:xfrm>
+            <a:off x="6812280" y="5349240"/>
+            <a:ext cx="457200" cy="457200"/>
+          </a:xfrm>
+          <a:prstGeom prst="rect">
+            <a:avLst/>
+          </a:prstGeom>
+          <a:solidFill>
+            <a:srgbClr val="2A78D6"/>
+          </a:solidFill>
+          <a:ln>
+            <a:noFill/>
+          </a:ln>
+          <a:effectLst/>
+        </p:spPr>
+        <p:style>
+          <a:lnRef idx="1">
+            <a:schemeClr val="accent1"/>
+          </a:lnRef>
+          <a:fillRef idx="3">
+            <a:schemeClr val="accent1"/>
+          </a:fillRef>
+          <a:effectRef idx="2">
+            <a:schemeClr val="accent1"/>
+          </a:effectRef>
+          <a:fontRef idx="minor">
+            <a:schemeClr val="lt1"/>
+          </a:fontRef>
+        </p:style>
+        <p:txBody>
+          <a:bodyPr rtlCol="0" anchor="ctr"/>
+          <a:lstStyle/>
+          <a:p>
+            <a:pPr algn="ctr"/>
+            <a:endParaRPr/>
+          </a:p>
+        </p:txBody>
+      </p:sp>
+      <p:sp>
+        <p:nvSpPr>
+          <p:cNvPr id="19" name="TextBox 18"/>
+          <p:cNvSpPr txBox="1"/>
+          <p:nvPr/>
+        </p:nvSpPr>
+        <p:spPr>
+          <a:xfrm>
+            <a:off x="6812280" y="5385816"/>
+            <a:ext cx="457200" cy="384048"/>
+          </a:xfrm>
+          <a:prstGeom prst="rect">
+            <a:avLst/>
+          </a:prstGeom>
+          <a:noFill/>
+        </p:spPr>
+        <p:txBody>
+          <a:bodyPr wrap="square" anchor="t">
+            <a:spAutoFit/>
+          </a:bodyPr>
+          <a:lstStyle/>
+          <a:p>
+            <a:pPr algn="ctr">
+              <a:lnSpc>
+                <a:spcPct val="100000"/>
+              </a:lnSpc>
+            </a:pPr>
+            <a:r>
+              <a:rPr sz="1500" b="1" i="0">
+                <a:solidFill>
+                  <a:srgbClr val="FFFFFF"/>
+                </a:solidFill>
+                <a:latin typeface="Arial"/>
+              </a:rPr>
+              <a:t>Q5</a:t>
+            </a:r>
+          </a:p>
+        </p:txBody>
+      </p:sp>
+      <p:sp>
+        <p:nvSpPr>
+          <p:cNvPr id="20" name="TextBox 19"/>
+          <p:cNvSpPr txBox="1"/>
+          <p:nvPr/>
+        </p:nvSpPr>
+        <p:spPr>
+          <a:xfrm>
+            <a:off x="7452360" y="5349240"/>
+            <a:ext cx="4023360" cy="777240"/>
+          </a:xfrm>
+          <a:prstGeom prst="rect">
+            <a:avLst/>
+          </a:prstGeom>
+          <a:noFill/>
+        </p:spPr>
+        <p:txBody>
+          <a:bodyPr wrap="square" anchor="ctr">
+            <a:spAutoFit/>
+          </a:bodyPr>
+          <a:lstStyle/>
+          <a:p>
+            <a:pPr algn="l">
+              <a:lnSpc>
+                <a:spcPct val="100000"/>
+              </a:lnSpc>
+            </a:pPr>
+            <a:r>
+              <a:rPr sz="1450" b="0" i="0">
+                <a:solidFill>
+                  <a:srgbClr val="0B0B0B"/>
+                </a:solidFill>
+                <a:latin typeface="Arial"/>
+              </a:rPr>
+              <a:t>Does trip demand or fare change on rainy or snowy days? (cross-source join)</a:t>
             </a:r>
           </a:p>
         </p:txBody>
@@ -6781,7 +7450,7 @@
                 </a:solidFill>
                 <a:latin typeface="Arial"/>
               </a:rPr>
-              <a:t>42 pytest unit tests across preprocessing, analytics, ML, and UI helpers (TDD)</a:t>
+              <a:t>50 pytest unit tests across preprocessing, analytics, ML, and UI helpers (TDD)</a:t>
             </a:r>
           </a:p>
         </p:txBody>
@@ -7391,7 +8060,7 @@
                 </a:solidFill>
                 <a:latin typeface="Arial"/>
               </a:rPr>
-              <a:t>Same page renders the Q1–Q4 analytics results (tables + charts)</a:t>
+              <a:t>Same page renders the Q1–Q5 analytics results (tables + charts)</a:t>
             </a:r>
           </a:p>
         </p:txBody>
@@ -8209,7 +8878,7 @@
                 </a:solidFill>
                 <a:latin typeface="Arial"/>
               </a:rPr>
-              <a:t>177,174,900</a:t>
+              <a:t>177,171,999</a:t>
             </a:r>
           </a:p>
         </p:txBody>
@@ -8666,7 +9335,7 @@
                 </a:solidFill>
                 <a:latin typeface="Arial"/>
               </a:rPr>
-              <a:t>Next: run each of the 4 queries and walk through what they show.</a:t>
+              <a:t>Next: run each of the 5 queries and walk through what they show.</a:t>
             </a:r>
           </a:p>
         </p:txBody>

</xml_diff>